<commit_message>
Añade la URL del repositorio a la memoria y la presentación
</commit_message>
<xml_diff>
--- a/docs/presentacion/clandestino-defensa.pptx
+++ b/docs/presentacion/clandestino-defensa.pptx
@@ -122,62 +122,62 @@
   <p:extLst>
     <p:ext uri="{521415D9-36F7-43E2-AB2F-B90AF26B5E84}">
       <p14:sectionLst xmlns:p14="http://schemas.microsoft.com/office/powerpoint/2010/main">
-        <p14:section name="Portada" id="{144dc66f-3058-92b7-dfe8-7a5a4de3ab85}">
+        <p14:section name="Portada" id="{77bf443b-7f73-60b4-6634-14bc3989c977}">
           <p14:sldIdLst>
             <p14:sldId id="256"/>
           </p14:sldIdLst>
         </p14:section>
-        <p14:section name="Recorrido" id="{0d0a58cf-f234-536f-d8cf-d19f03e8a853}">
+        <p14:section name="Recorrido" id="{f145965f-91e8-90c0-46b6-388ee6db6f06}">
           <p14:sldIdLst>
             <p14:sldId id="257"/>
           </p14:sldIdLst>
         </p14:section>
-        <p14:section name="Introducción" id="{c80c1899-cd0e-4b9e-712c-cd9898faf35c}">
+        <p14:section name="Introducción" id="{6f8c4852-b526-5241-eecb-49fa743f9975}">
           <p14:sldIdLst>
             <p14:sldId id="258"/>
             <p14:sldId id="259"/>
           </p14:sldIdLst>
         </p14:section>
-        <p14:section name="Objetivos" id="{b30607e7-981b-d267-c11c-5b82bcdbab3b}">
+        <p14:section name="Objetivos" id="{a69e6d92-a6a2-33bd-9dd0-8306543422a8}">
           <p14:sldIdLst>
             <p14:sldId id="260"/>
           </p14:sldIdLst>
         </p14:section>
-        <p14:section name="Contenidos" id="{e2b21640-25d3-fa6c-269f-3dc93b6c939c}">
+        <p14:section name="Contenidos" id="{ad02b7a6-ad3a-f3a4-ea2c-4eeb00bae253}">
           <p14:sldIdLst>
             <p14:sldId id="261"/>
             <p14:sldId id="262"/>
             <p14:sldId id="263"/>
           </p14:sldIdLst>
         </p14:section>
-        <p14:section name="Metodología" id="{c20d3521-93fe-232a-d2e0-14ff7140591d}">
+        <p14:section name="Metodología" id="{a615a31d-06f9-c09f-c8fd-2964805a62e1}">
           <p14:sldIdLst>
             <p14:sldId id="264"/>
           </p14:sldIdLst>
         </p14:section>
-        <p14:section name="Desarrollo" id="{7a201909-d760-4c6e-4cb5-525b000899ba}">
+        <p14:section name="Desarrollo" id="{e1016035-d6a0-24e1-8163-db098277bf00}">
           <p14:sldIdLst>
             <p14:sldId id="265"/>
             <p14:sldId id="266"/>
           </p14:sldIdLst>
         </p14:section>
-        <p14:section name="Concurrencia" id="{6e6ad0be-4550-4505-695d-f4e86dc2bcc0}">
+        <p14:section name="Concurrencia" id="{4055bc96-6235-06ec-38aa-09c80d96e847}">
           <p14:sldIdLst>
             <p14:sldId id="267"/>
           </p14:sldIdLst>
         </p14:section>
-        <p14:section name="Pruebas y demo" id="{f7ee7ad1-b19c-fd83-93c4-674a5fa01e8f}">
+        <p14:section name="Pruebas y demo" id="{34e4fa41-f3e3-febc-af7b-38f03c9a5a24}">
           <p14:sldIdLst>
             <p14:sldId id="268"/>
             <p14:sldId id="269"/>
           </p14:sldIdLst>
         </p14:section>
-        <p14:section name="Conclusiones" id="{077438c4-f38a-8d30-78c8-9ae608373e93}">
+        <p14:section name="Conclusiones" id="{c144f844-e184-5b2c-cca0-9e25a4a7c18e}">
           <p14:sldIdLst>
             <p14:sldId id="270"/>
           </p14:sldIdLst>
         </p14:section>
-        <p14:section name="Cierre" id="{24d15681-bf1c-1ed8-9270-f9b9fc202fb8}">
+        <p14:section name="Cierre" id="{3b6ff376-34c3-891c-04ce-047d1f2e5ad6}">
           <p14:sldIdLst>
             <p14:sldId id="271"/>
           </p14:sldIdLst>
@@ -8122,7 +8122,7 @@
                   <a:schemeClr val="accent3"/>
                 </a:solidFill>
               </a:rPr>
-              <a:t>Código y memoria: [URL del repositorio]</a:t>
+              <a:t>github.com/Jhonnatanospina/clandestino-tfg</a:t>
             </a:r>
             <a:endParaRPr lang="en-US" sz="1600" dirty="0"/>
           </a:p>

</xml_diff>